<commit_message>
Rapor ve sunum: Çanakkale kovanı 6 kWp, ≈1,5×, ≈1 gün; ≈218 / ≈63 bin $
Co-Authored-By: Claude Opus 5.5 <noreply@anthropic.com>
</commit_message>
<xml_diff>
--- a/belgeler/AERO-GUARD_V3_Sunum.pptx
+++ b/belgeler/AERO-GUARD_V3_Sunum.pptx
@@ -147,7 +147,7 @@
                 </a:solidFill>
                 <a:latin typeface="Calibri"/>
               </a:rPr>
-              <a:t>Mini kovan · kWh / yıl (ön tasarım)</a:t>
+              <a:t>Çanakkale kovanı · kWh / yıl (ön tasarım, 6 kWp güneş)</a:t>
             </a:r>
           </a:p>
         </c:rich>
@@ -266,13 +266,13 @@
                 <c:formatCode>General</c:formatCode>
                 <c:ptCount val="3"/>
                 <c:pt idx="0">
-                  <c:v>3650</c:v>
+                  <c:v>5860</c:v>
                 </c:pt>
                 <c:pt idx="1">
-                  <c:v>4745</c:v>
+                  <c:v>7620</c:v>
                 </c:pt>
                 <c:pt idx="2">
-                  <c:v>8550</c:v>
+                  <c:v>11250</c:v>
                 </c:pt>
               </c:numCache>
             </c:numRef>
@@ -353,7 +353,7 @@
         <c:axId val="2094734552"/>
         <c:scaling>
           <c:orientation val="minMax"/>
-          <c:max val="10500"/>
+          <c:max val="13800"/>
           <c:min val="0"/>
         </c:scaling>
         <c:delete val="1"/>
@@ -897,7 +897,7 @@
           <a:p>
             <a:r>
               <a:rPr lang="en-US" dirty="0"/>
-              <a:t>(~45 sn) Enerji hesabını önce iki hücreli mini kovan için yaptık: güneş ve türbin yılda yaklaşık 8.550 kilovatsaat üretiyor, bu tasarım yükünün 1,8 katı. Açık söyleyelim: Çanakkale kovanında hücre sayısı dörde çıkıyor ve en büyük kalem olan iklimlendirme ikiye katlanıyor; oran yaklaşık 1,2'ye iniyor. Bu yüzden enerji bütçesini kovan boyuna göre yeniden yapacağız. Türbini Ek 14'e göre yerleştiriyoruz: pistten 250 metrede izin verilen yükseklik yaklaşık 15,7 metre, türbinimiz yaklaşık 9 metre. Doğrudan karbon azaltımı havalimanı başına yılda yaklaşık 10 ton; küçük bir rakam, asıl kazanç dolaylı etkilerde.</a:t>
+              <a:t>(~45 sn) Enerji hesabını kovan boyuna göre yapıyoruz. Önerdiğimiz Çanakkale kovanında dört hücre ve iki nöbetçi direk günde yaklaşık 16 kilovatsaat tüketiyor; en büyük kalem iklimlendirme. Mini kovandaki 4 kilovatlık güneşle üretim, tasarım yükünün ancak 1,1 katı olurdu; bu yüzden güneşi 6 kilovata çıkardık, maliyeti yaklaşık 2.500 dolar. Böylece yılda yaklaşık 11.250 kilovatsaat üretiyoruz, tasarım yükünün 1,5 katı; batarya yaklaşık bir gün yetiyor. Türbini Ek 14'e göre yerleştiriyoruz: pistten 250 metrede izin verilen yükseklik yaklaşık 15,7 metre, türbinimiz yaklaşık 9 metre. Doğrudan karbon azaltımı havalimanı başına yılda yaklaşık 10 ton; küçük bir rakam, asıl kazanç dolaylı etkilerde.</a:t>
             </a:r>
             <a:endParaRPr lang="en-US" dirty="0"/>
           </a:p>
@@ -1161,7 +1161,7 @@
           <a:p>
             <a:r>
               <a:rPr lang="en-US" dirty="0"/>
-              <a:t>(~40 sn) Maliyeti artık kovan boyuna göre veriyoruz; hepsi artı eksi yüzde 30 belirsizlikli ön tahmin. İki kâşifli mini kovan yaklaşık 124 bin dolar. Önerdiğimiz Çanakkale kovanı bekçi, işçi, nöbetçi kameralar ve güvenli konumla yaklaşık 215 bin dolar; beş yıla yayınca yılda yaklaşık 62 bin. Soğuk iklim için kış kovanı bakıcı rolüyle yaklaşık 220 bin. Bölgesel havalimanlarının bütçesi kısıtlı olduğu için hizmet olarak drone modelini öneriyoruz: havalimanı kurulum parası ödemiyor, kovan boyuna göre abonelik ödüyor.</a:t>
+              <a:t>(~40 sn) Maliyeti artık kovan boyuna göre veriyoruz; hepsi artı eksi yüzde 30 belirsizlikli ön tahmin. İki kâşifli mini kovan yaklaşık 124 bin dolar. Önerdiğimiz Çanakkale kovanı bekçi, işçi, nöbetçi kameralar, güvenli konum ve 6 kilovatlık güneşle yaklaşık 218 bin dolar; beş yıla yayınca yılda yaklaşık 63 bin. Soğuk iklim için kış kovanı bakıcı rolüyle yaklaşık 223 bin. Bölgesel havalimanlarının bütçesi kısıtlı olduğu için hizmet olarak drone modelini öneriyoruz: havalimanı kurulum parası ödemiyor, kovan boyuna göre abonelik ödüyor.</a:t>
             </a:r>
             <a:endParaRPr lang="en-US" dirty="0"/>
           </a:p>
@@ -3207,7 +3207,7 @@
                 <a:ea typeface="Calibri" pitchFamily="34" charset="-122"/>
                 <a:cs typeface="Calibri" pitchFamily="34" charset="-120"/>
               </a:rPr>
-              <a:t>Çanakkale kovanı (4 hücre): </a:t>
+              <a:t>Çanakkale kovanı: </a:t>
             </a:r>
             <a:pPr indent="0" marL="0">
               <a:buNone/>
@@ -3221,7 +3221,7 @@
                 <a:ea typeface="Calibri" pitchFamily="34" charset="-122"/>
                 <a:cs typeface="Calibri" pitchFamily="34" charset="-120"/>
               </a:rPr>
-              <a:t>iklimlendirme iki katına çıkar, oran ≈1,2×'e iner; nöbetçi ve güvenli konum yükü hariç. Enerji bütçesi kovan boyuna göre yenilenecek.</a:t>
+              <a:t>4 hücre + 2 nöbetçi ≈16 kWh/gün. 4 kWp güneşle oran ≈1,1×'e inerdi; bu yüzden 6 kWp (+≈2,5 bin $). Mini kovan (2 hücre, 4 kWp): 1,8×, ≈1,5 gün.</a:t>
             </a:r>
             <a:endParaRPr lang="en-US" sz="1300" dirty="0"/>
           </a:p>
@@ -3260,7 +3260,7 @@
                 <a:ea typeface="Calibri" pitchFamily="34" charset="-122"/>
                 <a:cs typeface="Calibri" pitchFamily="34" charset="-120"/>
               </a:rPr>
-              <a:t>1,8×</a:t>
+              <a:t>≈1,5×</a:t>
             </a:r>
             <a:endParaRPr lang="en-US" sz="4000" dirty="0"/>
           </a:p>
@@ -3299,7 +3299,7 @@
                 <a:ea typeface="Calibri" pitchFamily="34" charset="-122"/>
                 <a:cs typeface="Calibri" pitchFamily="34" charset="-120"/>
               </a:rPr>
-              <a:t>üretim / tasarım yükü (mini kovan)</a:t>
+              <a:t>üretim / tasarım yükü (Çanakkale kovanı, 6 kWp) · batarya ≈1 gün</a:t>
             </a:r>
             <a:endParaRPr lang="en-US" sz="1300" dirty="0"/>
           </a:p>
@@ -6728,7 +6728,7 @@
                 <a:ea typeface="Calibri" pitchFamily="34" charset="-122"/>
                 <a:cs typeface="Calibri" pitchFamily="34" charset="-120"/>
               </a:rPr>
-              <a:t>≈215 bin $</a:t>
+              <a:t>≈218 bin $</a:t>
             </a:r>
             <a:endParaRPr lang="en-US" sz="3200" dirty="0"/>
           </a:p>
@@ -6806,7 +6806,7 @@
                 <a:ea typeface="Calibri" pitchFamily="34" charset="-122"/>
                 <a:cs typeface="Calibri" pitchFamily="34" charset="-120"/>
               </a:rPr>
-              <a:t>4 drone + nöbetçiler + güvenli konum · ≈62 bin $/yıl</a:t>
+              <a:t>4 drone + nöbetçiler + güvenli konum + 6 kWp güneş · ≈63 bin $/yıl</a:t>
             </a:r>
             <a:endParaRPr lang="en-US" sz="1300" dirty="0"/>
           </a:p>
@@ -6872,7 +6872,7 @@
                 <a:ea typeface="Calibri" pitchFamily="34" charset="-122"/>
                 <a:cs typeface="Calibri" pitchFamily="34" charset="-120"/>
               </a:rPr>
-              <a:t>≈220 bin $</a:t>
+              <a:t>≈223 bin $</a:t>
             </a:r>
             <a:endParaRPr lang="en-US" sz="3200" dirty="0"/>
           </a:p>
@@ -6950,7 +6950,7 @@
                 <a:ea typeface="Calibri" pitchFamily="34" charset="-122"/>
                 <a:cs typeface="Calibri" pitchFamily="34" charset="-120"/>
               </a:rPr>
-              <a:t>Çanakkale kovanı + bakıcı rolü · ≈63 bin $/yıl</a:t>
+              <a:t>Çanakkale kovanı + bakıcı rolü · ≈64 bin $/yıl</a:t>
             </a:r>
             <a:endParaRPr lang="en-US" sz="1300" dirty="0"/>
           </a:p>

</xml_diff>

<commit_message>
Rapor ve sunum: V3 son hali, sıkıştırılmış rapor ve konuşma notları
Co-Authored-By: Claude Opus 5.5 <noreply@anthropic.com>
</commit_message>
<xml_diff>
--- a/belgeler/AERO-GUARD_V3_Sunum.pptx
+++ b/belgeler/AERO-GUARD_V3_Sunum.pptx
@@ -809,7 +809,7 @@
           <a:p>
             <a:r>
               <a:rPr lang="en-US" dirty="0"/>
-              <a:t>(~30 sn) Merhaba, biz ÇOMÜ Bilgisayar Mühendisliği'nden AERO-GUARD ekibiyiz. AERO-GUARD, bölgesel havalimanları için kendi enerjisini üreten ve uçuş tarifesine göre çalışan bir drone kovanı. Mentörlerimiz projemizi bir arı kovanına benzetmişti; bu sürümde o benzetmeyi projenin omurgası yaptık. Bugün size bu kovanı ve sınırlarını anlatacağız.</a:t>
+              <a:t>(~25 sn) Merhaba, biz ÇOMÜ Bilgisayar Mühendisliği'nden AERO-GUARD ekibiyiz. AERO-GUARD, bölgesel havalimanları için kendi enerjisini üreten, uçuş tarifesine göre çalışan bir drone kovanı. Mentörlerimizin kovan benzetmesini bu sürümde projenin omurgası yaptık.</a:t>
             </a:r>
             <a:endParaRPr lang="en-US" dirty="0"/>
           </a:p>
@@ -897,7 +897,7 @@
           <a:p>
             <a:r>
               <a:rPr lang="en-US" dirty="0"/>
-              <a:t>(~45 sn) Enerji hesabını kovan boyuna göre yapıyoruz. Önerdiğimiz Çanakkale kovanında dört hücre ve iki nöbetçi direk günde yaklaşık 16 kilovatsaat tüketiyor; en büyük kalem iklimlendirme. Mini kovandaki 4 kilovatlık güneşle üretim, tasarım yükünün ancak 1,1 katı olurdu; bu yüzden güneşi 6 kilovata çıkardık, maliyeti yaklaşık 2.500 dolar. Böylece yılda yaklaşık 11.250 kilovatsaat üretiyoruz, tasarım yükünün 1,5 katı; batarya yaklaşık bir gün yetiyor. Türbini Ek 14'e göre yerleştiriyoruz: pistten 250 metrede izin verilen yükseklik yaklaşık 15,7 metre, türbinimiz yaklaşık 9 metre. Doğrudan karbon azaltımı havalimanı başına yılda yaklaşık 10 ton; küçük bir rakam, asıl kazanç dolaylı etkilerde.</a:t>
+              <a:t>(~40 sn) Enerji hesabını kovan boyuna göre yapıyoruz. Çanakkale kovanında dört hücre ve iki nöbetçi direk günde yaklaşık 16 kilovatsaat tüketiyor. Mini kovandaki 4 kilovatlık güneşle üretim tasarım yükünün ancak 1,1 katı olurdu; bu yüzden güneşi 6 kilovata çıkardık, maliyeti yaklaşık 2.500 dolar. Böylece üretim yükün 1,5 katı, batarya yaklaşık bir gün yetiyor. Türbin Ek 14'e uygun: pistten 250 metrede izin verilen yükseklik 15,7 metre, türbinimiz 9 metre. Doğrudan karbon azaltımı yılda yaklaşık 10 ton; asıl kazanç dolaylı etkilerde.</a:t>
             </a:r>
             <a:endParaRPr lang="en-US" dirty="0"/>
           </a:p>
@@ -985,7 +985,7 @@
           <a:p>
             <a:r>
               <a:rPr lang="en-US" dirty="0"/>
-              <a:t>(~40 sn) Teknolojilerin her biri tek başına yeni değil; bunu mentörlerimiz de söyledi. Sabit FOD radarları ve kuş radarları büyük havalimanlarında sürekli izleme sağlıyor ama pahalı ve tek görevli. Cranfield'da drone ile pist denetimi denendi ama tek görevli ve tarifeyle bağlantısızdı. AERO-GUARD bunları bölgesel havalimanı için tek bir kovanda birleştiriyor. Sınırımızı da gizlemiyoruz: sürekli FOD izlemesi yapmıyoruz, nöbetçi kameralar bir FOD radarı değil. Ama günde dört hareketli bir pistte her hareketten önce tarama yeterli güvenceyi veriyor.</a:t>
+              <a:t>(~30 sn) Teknolojilerin her biri tek başına yeni değil. FOD ve kuş radarları sürekli izleme sağlıyor ama pahalı ve tek görevli; Cranfield'daki drone denemesi tarifeyle bağlantısızdı. AERO-GUARD bunları bölgesel havalimanı için tek bir kovanda birleştiriyor. Sınırımızı da gizlemiyoruz: sürekli FOD izlemesi yapmıyoruz; ama günde dört hareketli bir pistte her hareketten önce tarama yeterli güvenceyi veriyor.</a:t>
             </a:r>
             <a:endParaRPr lang="en-US" dirty="0"/>
           </a:p>
@@ -1073,7 +1073,7 @@
           <a:p>
             <a:r>
               <a:rPr lang="en-US" dirty="0"/>
-              <a:t>(~40 sn) Jürinin aklındaki ilk soru muhtemelen şu: drone düşerse kendisi FOD olmaz mı? Kule onaylamadan kalkış yok. Sanal sınır drone'u 30 metrenin altında tutuyor, ADS-B yaklaşan uçağı algılıyor ve hareketin beş dakika öncesi ve sonrası hiçbir kast uçmuyor. Arıza olursa drone pist dışındaki acil iniş noktalarına iniyor ve indiği yer FOD bildirimi olarak kuleye gidiyor; her kalkıştan önce hücre kamerası pervaneleri kontrol ediyor. Çanakkale sivil-askeri bir havalimanı olduğu için görüntüler dışarı çıkmıyor. Rüzgâr sınırı aşılırsa ya da dondurucu yağış varsa sistem kenara çekiliyor.</a:t>
+              <a:t>(~35 sn) Akla gelen ilk soru şu: drone düşerse kendisi FOD olmaz mı? Kule onaylamadan kalkış yok. Sanal sınır drone'u 30 metrenin altında tutuyor, ADS-B yaklaşan uçağı algılıyor ve hareketin beş dakika öncesi ve sonrası kimse uçmuyor. Arıza olursa drone pist dışındaki acil iniş noktalarına iniyor ve indiği yer kuleye FOD olarak bildiriliyor. Görüntüler havalimanından çıkmıyor; rüzgâr sınırı aşılırsa ya da dondurucu yağış varsa sistem kenara çekiliyor.</a:t>
             </a:r>
             <a:endParaRPr lang="en-US" dirty="0"/>
           </a:p>
@@ -1161,7 +1161,7 @@
           <a:p>
             <a:r>
               <a:rPr lang="en-US" dirty="0"/>
-              <a:t>(~40 sn) Maliyeti artık kovan boyuna göre veriyoruz; hepsi artı eksi yüzde 30 belirsizlikli ön tahmin. İki kâşifli mini kovan yaklaşık 124 bin dolar. Önerdiğimiz Çanakkale kovanı bekçi, işçi, nöbetçi kameralar, güvenli konum ve 6 kilovatlık güneşle yaklaşık 218 bin dolar; beş yıla yayınca yılda yaklaşık 63 bin. Soğuk iklim için kış kovanı bakıcı rolüyle yaklaşık 223 bin. Bölgesel havalimanlarının bütçesi kısıtlı olduğu için hizmet olarak drone modelini öneriyoruz: havalimanı kurulum parası ödemiyor, kovan boyuna göre abonelik ödüyor.</a:t>
+              <a:t>(~35 sn) Maliyeti kovan boyuna göre veriyoruz; hepsi artı eksi yüzde 30'luk ön tahmin. Mini kovan yaklaşık 124 bin dolar. Önerdiğimiz Çanakkale kovanı bekçi, işçi, nöbetçi kameralar, güvenli konum ve 6 kilovatlık güneşle yaklaşık 218 bin dolar; beş yıla yayınca yılda yaklaşık 63 bin. Kış kovanı yaklaşık 223 bin. Hizmet olarak drone modelinde havalimanı kurulum parası ödemiyor, kovan boyuna göre abonelik ödüyor.</a:t>
             </a:r>
             <a:endParaRPr lang="en-US" dirty="0"/>
           </a:p>
@@ -1249,7 +1249,7 @@
           <a:p>
             <a:r>
               <a:rPr lang="en-US" dirty="0"/>
-              <a:t>(~35 sn) Yol haritamız 30 ay. İlk üç ayda FOD-A ile eğitilmiş YOLO demosunu ve kovan planlayıcısının simülasyonunu çıkarıyoruz; en uzun süreç izinler olduğu için ona ilk ayda başlıyoruz. Kastları aşamalı devreye alıyoruz: sınırlı pilot kâşiflerle, tam pilotta bekçi, işçi ve nöbetçiler ekleniyor; olgunluğu en düşük olan bakıcıyı soğuk iklimli bir havalimanıyla ayrı bir kış pilotunda deniyoruz. Son fazda 3-5 bölgesel havalimanına yayılıyoruz.</a:t>
+              <a:t>(~30 sn) Yol haritamız 30 ay. İlk üç ayda YOLO demosunu ve kovan planlayıcısının simülasyonunu çıkarıyoruz; en uzun süreç izinler olduğu için ona ilk ayda başlıyoruz. Kastları aşamalı alıyoruz: sınırlı pilot kâşiflerle, tam pilotta bekçi, işçi ve nöbetçiler; bakıcıyı soğuk iklimli bir havalimanıyla ayrı bir kış pilotunda deniyoruz. Son fazda 3-5 bölgesel havalimanına yayılıyoruz.</a:t>
             </a:r>
             <a:endParaRPr lang="en-US" dirty="0"/>
           </a:p>
@@ -1337,7 +1337,7 @@
           <a:p>
             <a:r>
               <a:rPr lang="en-US" dirty="0"/>
-              <a:t>(~25 sn) Özetle: AERO-GUARD, pahalı sistemlere erişemeyen bölgesel havalimanlarına her uçuştan önce doğrulanmış temiz pist sunuyor. Bunu görevine göre uzmanlaşmış, kendi enerjisini üreten küçük bir kovanla ve her rakamı varsayımıyla birlikte yapıyor. Teşekkür ederiz, sorularınızı bekliyoruz.</a:t>
+              <a:t>(~20 sn) Özetle: AERO-GUARD, pahalı sistemlere erişemeyen bölgesel havalimanlarına her uçuştan önce doğrulanmış temiz pist sunuyor; bunu görevine göre uzmanlaşmış, kendi enerjisini üreten küçük bir kovanla ve her rakamı varsayımıyla birlikte yapıyor. Teşekkür ederiz, sorularınızı bekliyoruz.</a:t>
             </a:r>
             <a:endParaRPr lang="en-US" dirty="0"/>
           </a:p>
@@ -1425,7 +1425,7 @@
           <a:p>
             <a:r>
               <a:rPr lang="en-US" dirty="0"/>
-              <a:t>(~45 sn) Problemimiz pistteki yabancı maddeler, yani FOD. Bir cıvata ya da taş parçası motora girdiğinde maliyet büyük. ABD Ulaştırma Araştırma Kurulu'nun derlediği tahminlere göre FOD ve kuş çarpmalarının dünya genelindeki toplam yıllık maliyeti yaklaşık 13,9 milyar dolar. Buna yaban hayatı ve pist yüzeyindeki çatlaklar da ekleniyor. Büyük havalimanlarında bunlar için özel sistemler var ama bölgesel havalimanlarında bu denetimlerin hepsi hâlâ gözle ve araçla yapılıyor.</a:t>
+              <a:t>(~35 sn) Problemimiz pistteki yabancı maddeler, yani FOD. Bir cıvata ya da taş parçası motora girdiğinde maliyet büyük: tahminlere göre FOD ve kuş çarpmalarının dünya genelindeki yıllık toplam maliyeti yaklaşık 13,9 milyar dolar. Buna yaban hayatı ve pist çatlakları ekleniyor. Büyük havalimanlarında özel sistemler var; bölgesel havalimanlarında ise bu denetimlerin hepsi hâlâ gözle ve araçla yapılıyor.</a:t>
             </a:r>
             <a:endParaRPr lang="en-US" dirty="0"/>
           </a:p>
@@ -1513,7 +1513,7 @@
           <a:p>
             <a:r>
               <a:rPr lang="en-US" dirty="0"/>
-              <a:t>(~45 sn) Başvuruda büyük havalimanlarını hedefliyorduk. Mentörlerimiz iki şey söyledi: Sabiha Gökçen'de dakikada bir hareket var, drone'a pistte zaman yok; büyük havalimanlarında bu iş için kurulu sistemler de var. Biz de soruyu tersine çevirdik: bu sistemlere erişemeyen kim? Cevap bölgesel havalimanları. Çanakkale, Sabiha Gökçen'in yaklaşık dört yüzde biri ölçeğinde; günde yaklaşık dört ticari hareket var. Önce kapsamı daralttık: 50 drone yerine 2 drone. Bu sürümde aynı odağı koruyup filoyu görevine göre uzmanlaştırdık: dört drone'luk küçük bir kovan.</a:t>
+              <a:t>(~40 sn) Başvuruda büyük havalimanlarını hedefliyorduk. Mentörlerimiz iki şey söyledi: Sabiha Gökçen'de dakikada bir hareket var, drone'a pistte zaman yok; büyük havalimanlarında kurulu sistemler de var. Biz de soruyu tersine çevirdik: bu sistemlere erişemeyen kim? Bölgesel havalimanları. Çanakkale, Sabiha Gökçen'in yaklaşık dört yüzde biri ölçeğinde; günde yaklaşık dört hareket var. Önce 50 drone yerine 2 drone'a indik; bu sürümde filoyu görevine göre uzmanlaştırıp dört drone'luk küçük bir kovan kurduk.</a:t>
             </a:r>
             <a:endParaRPr lang="en-US" dirty="0"/>
           </a:p>
@@ -1601,7 +1601,7 @@
           <a:p>
             <a:r>
               <a:rPr lang="en-US" dirty="0"/>
-              <a:t>(~50 sn) Kovanımız beş kasttan oluşuyor. İki kâşif pisti tarar ve nesneyi bulur. Bekçi kuşu ve hayvanı uzaklaştırır, çiti dolaşır. İşçi bulunan küçük nesneyi toplar. Bakıcı aslında işçinin ikinci rolü: başlığı değişince kış sabahı uçakta buzun yerini haritalar ve yalnızca soğuk iklim için önerdiğimiz kış kovanında var. İki nöbetçi direk de her iniş-kalkışta pisti izler. Drone'lar pistin iki ucundaki iki petekte duruyor; petek hücre ekleyerek büyüyor. Jüri "kraliçe kim?" diye sorarsa cevabımız şu: kovanın kararını kule ve insan verir.</a:t>
+              <a:t>(~45 sn) Kovanımız beş kasttan oluşuyor. İki kâşif pisti tarar ve nesneyi bulur. Bekçi kuşu ve hayvanı uzaklaştırır, çiti dolaşır. İşçi bulunan küçük nesneyi toplar. Bakıcı işçinin ikinci rolü: başlığı değişince kış sabahı uçakta buzun yerini haritalar; yalnızca kış kovanında var. İki nöbetçi direk de her iniş-kalkışta pisti izler. Drone'lar pistin iki ucundaki iki petekte duruyor ve petek hücre ekleyerek büyüyor. "Kraliçe kim?" diye sorarsanız: kovanın kararını kule ve insan verir.</a:t>
             </a:r>
             <a:endParaRPr lang="en-US" dirty="0"/>
           </a:p>
@@ -1689,7 +1689,7 @@
           <a:p>
             <a:r>
               <a:rPr lang="en-US" dirty="0"/>
-              <a:t>(~45 sn) Kovanın ana işi kâşiflerde. Her ticari hareketten yaklaşık 15 dakika önce iki kâşif aynı anda kalkıyor; her biri pistin yarısını, yani 1.175 metreyi, 20 metreden üç geçişle tarıyor. Bu irtifada piksel başına yaklaşık 3,5 milimetre çözünürlük var; 3 santimetrelik bir cıvata 8-9 piksel ediyor. Tarama kalkış ve iniş dahil yaklaşık 12 dakika. Kâşif sayısı tarama süresini belirliyor: üç kâşifle yaklaşık 9, dört kâşifle yaklaşık 8 dakika. Kazancımız hızdan çok tutarlılık: her tarama aynı rotada ve kayıtlı. Arıza olursa drone pist dışındaki kırmızı noktalara iniyor.</a:t>
+              <a:t>(~40 sn) Ana iş kâşiflerde. Her ticari hareketten yaklaşık 15 dakika önce iki kâşif aynı anda kalkıyor; her biri pistin yarısını 20 metreden üç geçişle tarıyor. Bu irtifada piksel başına yaklaşık 3,5 milimetre çözünürlük var; 3 santimlik bir cıvata 8-9 piksel ediyor. Tarama yaklaşık 12 dakika; üç kâşifle 9, dört kâşifle 8 dakikaya iniyor. Kazancımız hızdan çok tutarlılık: her tarama aynı rotada ve kayıtlı. Arıza olursa drone pist dışındaki kırmızı noktalara iniyor.</a:t>
             </a:r>
             <a:endParaRPr lang="en-US" dirty="0"/>
           </a:p>
@@ -1777,7 +1777,7 @@
           <a:p>
             <a:r>
               <a:rPr lang="en-US" dirty="0"/>
-              <a:t>(~50 sn) V3'te iki yeni yetenek var ve ikisini de sınırıyla anlatıyoruz. İşçi, kâşifin bulduğu nesneyi operatör ve kule onayıyla topluyor. Piste inmiyor; 4 metrede asılı kalıp vinçle başlığı indiriyor. Metalde elektro-kalıcı mıknatıs var, güç kesilse bile bırakmıyor. Drone 2,7 kilo taşıyor, vinç ve başlık yaklaşık 1,2 kilo; bu yüzden sınırımız 1 kilo. Bakıcı ise yalnızca buz haritası çıkarıyor: sıvı sıkmıyor, "uçak temiz" demiyor. Dondurucu yağış ya da sis varsa uçmuyor, uçağın üzerinden hiç geçmiyor. Olgunluğu düşük, TRL 3-4; glikol tasarrufu için sayı vermiyoruz, pilotta ölçeceğiz.</a:t>
+              <a:t>(~45 sn) V3'te iki yeni yetenek var, ikisini de sınırıyla anlatıyoruz. İşçi, kâşifin bulduğu nesneyi operatör ve kule onayıyla topluyor. Piste inmiyor; 4 metrede asılı kalıp vinçle başlığı indiriyor, metalde güç kesilse de bırakmayan mıknatıs kullanıyor. Drone 2,7 kilo taşıyor, vinç ve başlık 1,2 kilo; sınırımız bu yüzden 1 kilo. Bakıcı yalnızca buz haritası çıkarıyor: sıvı sıkmıyor, "uçak temiz" demiyor, dondurucu yağışta uçmuyor, uçağın üzerinden hiç geçmiyor. Olgunluğu düşük, TRL 3-4; glikol tasarrufu için sayı vermiyoruz, pilotta ölçeceğiz.</a:t>
             </a:r>
             <a:endParaRPr lang="en-US" dirty="0"/>
           </a:p>
@@ -1865,7 +1865,7 @@
           <a:p>
             <a:r>
               <a:rPr lang="en-US" dirty="0"/>
-              <a:t>(~50 sn) Ticari hareket sırasında drone'lar yerde; pisti nöbetçi kameralar izliyor. Bir yangın ya da pist dışına çıkma olursa YZ bunu kuleye bildiriyor; hedefimiz 10 saniyenin altı. Kule onaylarsa en yakın uygun drone yaklaşık bir dakikada kalkıp ekibe havadan termal görüntü veriyor. ICAO itfaiyenin pistin her noktasına 3 dakikada ulaşmasını hedefliyor; biz itfaiyeden önce varırız demiyoruz, ilk görürüz diyoruz. Ortada on iki senaryo var. Sağda karıştırma: EASA Akdeniz'de GNSS karıştırma ve aldatmanın arttığını söylüyor. Önlemimiz katmanlı: sinyal bozuksa kalkış yok, konum birden fazla kaynaktan geliyor, bağlantı şifreli ve yedekli. Karıştırıcı kullanmıyoruz; bu yasal değil.</a:t>
+              <a:t>(~45 sn) Hareket sırasında drone'lar yerde; pisti nöbetçi kameralar izliyor. Yangın ya da pist dışına çıkma olursa YZ kuleyi uyarıyor; hedefimiz 10 saniyenin altı. Kule onaylarsa en yakın drone yaklaşık bir dakikada kalkıp ekibe termal görüntü veriyor. ICAO itfaiyenin pistin her noktasına 3 dakikada ulaşmasını hedefliyor; biz önce varırız demiyoruz, ilk görürüz diyoruz. Sağda karıştırma: EASA, Akdeniz'de GNSS karıştırmanın arttığını söylüyor. Sinyal bozuksa kalkış yok, konum birden fazla kaynaktan geliyor, bağlantı şifreli ve yedekli. Karıştırıcı kullanmıyoruz; bu yasal değil.</a:t>
             </a:r>
             <a:endParaRPr lang="en-US" dirty="0"/>
           </a:p>
@@ -1953,7 +1953,7 @@
           <a:p>
             <a:r>
               <a:rPr lang="en-US" dirty="0"/>
-              <a:t>(~45 sn) Mentörümüzün itirazına cevabımız hâlâ aynı: sistem uçuş tarifesini okuyor. Temsili bir günde dört ticari hareket var. Kâşifler her hareketten önce tarıyor; bekçi şafakta, gün batımında ve çit boyunca uçuyor; işçi yalnızca kâşif bir şey bulunca kalkıyor; bakıcı satırı sadece kış kovanında var. Farklı kastlar aynı anda farklı bölgelerde çalışabiliyor. Pembe bantlar hareketin beş dakika öncesi ve sonrası: bu sürede hiçbir kast uçmuyor ve kule onaylamadan hiçbir drone kalkmıyor.</a:t>
+              <a:t>(~35 sn) Mentörümüzün itirazına cevabımız aynı: sistem uçuş tarifesini okuyor. Kâşifler her hareketten önce tarıyor; bekçi şafakta, gün batımında ve çit boyunca uçuyor; işçi yalnızca bir şey bulununca kalkıyor. Kastlar aynı anda farklı bölgelerde çalışabiliyor. Pembe bantlar hareketin beş dakika öncesi ve sonrası: bu sürede hiçbir kast uçmuyor ve kule onayı olmadan hiçbir drone kalkmıyor.</a:t>
             </a:r>
             <a:endParaRPr lang="en-US" dirty="0"/>
           </a:p>
@@ -2041,7 +2041,7 @@
           <a:p>
             <a:r>
               <a:rPr lang="en-US" dirty="0"/>
-              <a:t>(~40 sn) YZ tarafında açık kaynaklı FOD-A veri setiyle başlıyoruz: 31 sınıf, 30 binden fazla etiketli örnek. Sonra Çanakkale pistinde kontrollü bıraktığımız test nesneleriyle ince ayar yapıyoruz; operatörün her onayı ya da reddi modele yeni etiket olarak dönüyor. En önemlisi: sistem pisti asla kendisi açmıyor. Pilot hedeflerimiz tabloda; V3 ile iki gösterge ekledik: nöbetçinin kuleyi uyarma süresi ve tespitten temizliğe geçen süre. Ekip üyelerimizin bulunduğu takım TEKNOFEST 2026 Sağlıkta YZ'de finale kalmıştı; bu tecrübeyi buraya taşıyoruz.</a:t>
+              <a:t>(~30 sn) YZ tarafında açık FOD-A veri setiyle başlıyoruz: 31 sınıf, 30 binden fazla örnek. Çanakkale pistinde kontrollü bıraktığımız nesnelerle ince ayar yapıyoruz; operatörün her kararı modele geri dönüyor. Sistem pisti asla kendisi açmıyor. V3 ile iki gösterge ekledik: nöbetçinin kuleyi uyarma süresi ve tespitten temizliğe geçen süre. TEKNOFEST'te finale kalan bir takımın tecrübesini de buraya taşıyoruz.</a:t>
             </a:r>
             <a:endParaRPr lang="en-US" dirty="0"/>
           </a:p>

</xml_diff>